<commit_message>
Release converter accuracy improvements and secure Figma plugin
Integrate text ordering, lists, spacing, glyph outlines, host text transforms, and PowerPoint container staging. Add the authenticated bridge with per-install credentials and durable downloads. Keep fixtures synthetic, credentials external, and fonts unbundled.
</commit_message>
<xml_diff>
--- a/test/fixtures/golden/synthetic.pptx
+++ b/test/fixtures/golden/synthetic.pptx
@@ -1,6 +1,6 @@
 
 <file path=ppt/presentation.xml><?xml version="1.0" encoding="utf-8"?>
-<p:presentation xmlns:a="http://schemas.openxmlformats.org/drawingml/2006/main" xmlns:r="http://schemas.openxmlformats.org/officeDocument/2006/relationships" xmlns:p="http://schemas.openxmlformats.org/presentationml/2006/main" saveSubsetFonts="1">
+<p:presentation xmlns:a="http://schemas.openxmlformats.org/drawingml/2006/main" xmlns:r="http://schemas.openxmlformats.org/officeDocument/2006/relationships" xmlns:p="http://schemas.openxmlformats.org/presentationml/2006/main">
   <p:sldMasterIdLst>
     <p:sldMasterId id="2147483648" r:id="rId1"/>
   </p:sldMasterIdLst>
@@ -607,7 +607,7 @@
           </a:bodyPr>
           <a:lstStyle/>
           <a:p>
-            <a:pPr algn="l" marL="171450" indent="-171450">
+            <a:pPr algn="l" lvl="0" marL="171450" indent="-171450">
               <a:lnSpc>
                 <a:spcPts val="1800"/>
               </a:lnSpc>
@@ -618,6 +618,7 @@
                 <a:spcPts val="0"/>
               </a:spcAft>
               <a:buFont typeface="Arial"/>
+              <a:buSzPct val="100000"/>
               <a:buChar char="•"/>
             </a:pPr>
             <a:r>
@@ -634,7 +635,7 @@
             <a:endParaRPr lang="en-US" sz="1350"/>
           </a:p>
           <a:p>
-            <a:pPr algn="l" marL="171450" indent="-171450">
+            <a:pPr algn="l" lvl="0" marL="171450" indent="-171450">
               <a:lnSpc>
                 <a:spcPts val="1800"/>
               </a:lnSpc>
@@ -645,6 +646,7 @@
                 <a:spcPts val="0"/>
               </a:spcAft>
               <a:buFont typeface="Arial"/>
+              <a:buSzPct val="100000"/>
               <a:buChar char="•"/>
             </a:pPr>
             <a:r>

</xml_diff>